<commit_message>
Limpa o repositorio e mantem apenas a apresentacao
Remove a versao anterior do painel (index.html, data.json, scripts e
workflows) e o projeto Next.js. O historico do git preserva tudo, caso
seja preciso recuperar.
</commit_message>
<xml_diff>
--- a/apresentacao/TV-Comercial-Vixtra-Setembro-2026.pptx
+++ b/apresentacao/TV-Comercial-Vixtra-Setembro-2026.pptx
@@ -141,7 +141,7 @@
               <c:strCache>
                 <c:ptCount val="1"/>
                 <c:pt idx="0">
-                  <c:v>Nova operação</c:v>
+                  <c:v>Aumento de Volume Tomado</c:v>
                 </c:pt>
               </c:strCache>
             </c:strRef>
@@ -184,13 +184,13 @@
                 <c:ptCount val="4"/>
                 <c:lvl>
                   <c:pt idx="0">
-                    <c:v>Carlos Ferrarezi</c:v>
+                    <c:v>Antonio Mourão</c:v>
                   </c:pt>
                   <c:pt idx="1">
                     <c:v>André Vitoretti</c:v>
                   </c:pt>
                   <c:pt idx="2">
-                    <c:v>Antonio Mourão</c:v>
+                    <c:v>Carlos Ferrarezi</c:v>
                   </c:pt>
                   <c:pt idx="3">
                     <c:v>Tiago Viel</c:v>
@@ -206,16 +206,16 @@
                 <c:formatCode>General</c:formatCode>
                 <c:ptCount val="4"/>
                 <c:pt idx="0">
-                  <c:v>27626534</c:v>
+                  <c:v>10343215</c:v>
                 </c:pt>
                 <c:pt idx="1">
-                  <c:v>16572000</c:v>
+                  <c:v>0</c:v>
                 </c:pt>
                 <c:pt idx="2">
-                  <c:v>4021000</c:v>
+                  <c:v>600000</c:v>
                 </c:pt>
                 <c:pt idx="3">
-                  <c:v>0</c:v>
+                  <c:v>2000000</c:v>
                 </c:pt>
               </c:numCache>
             </c:numRef>
@@ -273,13 +273,13 @@
                 <c:ptCount val="4"/>
                 <c:lvl>
                   <c:pt idx="0">
-                    <c:v>Carlos Ferrarezi</c:v>
+                    <c:v>Antonio Mourão</c:v>
                   </c:pt>
                   <c:pt idx="1">
                     <c:v>André Vitoretti</c:v>
                   </c:pt>
                   <c:pt idx="2">
-                    <c:v>Antonio Mourão</c:v>
+                    <c:v>Carlos Ferrarezi</c:v>
                   </c:pt>
                   <c:pt idx="3">
                     <c:v>Tiago Viel</c:v>
@@ -295,16 +295,16 @@
                 <c:formatCode>General</c:formatCode>
                 <c:ptCount val="4"/>
                 <c:pt idx="0">
-                  <c:v>1000000</c:v>
+                  <c:v>14116000</c:v>
                 </c:pt>
                 <c:pt idx="1">
-                  <c:v>4560000</c:v>
+                  <c:v>4519000</c:v>
                 </c:pt>
                 <c:pt idx="2">
-                  <c:v>8352000</c:v>
+                  <c:v>3590043</c:v>
                 </c:pt>
                 <c:pt idx="3">
-                  <c:v>1000000</c:v>
+                  <c:v>0</c:v>
                 </c:pt>
               </c:numCache>
             </c:numRef>
@@ -1578,7 +1578,7 @@
           <a:p>
             <a:r>
               <a:rPr lang="en-US" dirty="0"/>
-              <a:t>Fonte: HubSpot, relatório "Farmers - Funil de Operação" (155079282), pipeline de Farming.</a:t>
+              <a:t>Forecasting por farmer. Antonio Mourão: R$ 10.343.215 de aumento e R$ 14.116.000 de renovação. André Vitoretti: R$ 4.519.000 de renovação. Carlos Ferrarezi: R$ 600.000 de aumento e R$ 3.590.043 de renovação. Tiago Viel: R$ 2.000.000 de aumento. Para editar os números, clique no gráfico e abra a planilha.</a:t>
             </a:r>
             <a:endParaRPr lang="en-US" dirty="0"/>
           </a:p>
@@ -10385,7 +10385,7 @@
                 <a:ea typeface="Arial" pitchFamily="34" charset="-122"/>
                 <a:cs typeface="Arial" pitchFamily="34" charset="-120"/>
               </a:rPr>
-              <a:t>Funil de operação por farmer</a:t>
+              <a:t>Forecasting por Farmer</a:t>
             </a:r>
             <a:endParaRPr lang="en-US" sz="3800" dirty="0"/>
           </a:p>
@@ -10552,7 +10552,7 @@
                 <a:ea typeface="Courier New" pitchFamily="34" charset="-122"/>
                 <a:cs typeface="Courier New" pitchFamily="34" charset="-120"/>
               </a:rPr>
-              <a:t>Nova operação</a:t>
+              <a:t>Aumento de volume</a:t>
             </a:r>
             <a:endParaRPr lang="en-US" sz="1000" dirty="0"/>
           </a:p>
@@ -10591,7 +10591,7 @@
                 <a:ea typeface="Arial" pitchFamily="34" charset="-122"/>
                 <a:cs typeface="Arial" pitchFamily="34" charset="-120"/>
               </a:rPr>
-              <a:t>R$ 48,2M</a:t>
+              <a:t>R$ 12,9M</a:t>
             </a:r>
             <a:endParaRPr lang="en-US" sz="2400" dirty="0"/>
           </a:p>
@@ -10703,7 +10703,7 @@
                 <a:ea typeface="Arial" pitchFamily="34" charset="-122"/>
                 <a:cs typeface="Arial" pitchFamily="34" charset="-120"/>
               </a:rPr>
-              <a:t>R$ 14,9M</a:t>
+              <a:t>R$ 22,2M</a:t>
             </a:r>
             <a:endParaRPr lang="en-US" sz="2400" dirty="0"/>
           </a:p>
@@ -10776,7 +10776,7 @@
                 <a:ea typeface="Courier New" pitchFamily="34" charset="-122"/>
                 <a:cs typeface="Courier New" pitchFamily="34" charset="-120"/>
               </a:rPr>
-              <a:t>Total no funil</a:t>
+              <a:t>Total previsto</a:t>
             </a:r>
             <a:endParaRPr lang="en-US" sz="1000" dirty="0"/>
           </a:p>
@@ -10815,7 +10815,7 @@
                 <a:ea typeface="Arial" pitchFamily="34" charset="-122"/>
                 <a:cs typeface="Arial" pitchFamily="34" charset="-120"/>
               </a:rPr>
-              <a:t>R$ 63,1M</a:t>
+              <a:t>R$ 35,2M</a:t>
             </a:r>
             <a:endParaRPr lang="en-US" sz="2400" dirty="0"/>
           </a:p>

</xml_diff>